<commit_message>
Fix the PowerPoint repair prompt on slide downloads
Fix the PowerPoint repair prompt on slide downloads
</commit_message>
<xml_diff>
--- a/deck/slides/the-ai-control-plane-slide-01.pptx
+++ b/deck/slides/the-ai-control-plane-slide-01.pptx
@@ -491,7 +491,12 @@
             <p:ph type="sldImg"/>
           </p:nvPr>
         </p:nvSpPr>
-        <p:spPr/>
+        <p:spPr>
+          <a:xfrm>
+            <a:off x="457200" y="762000"/>
+            <a:ext cx="5943600" cy="3343275"/>
+          </a:xfrm>
+        </p:spPr>
       </p:sp>
       <p:sp>
         <p:nvSpPr>
@@ -503,7 +508,12 @@
             <p:ph type="body" idx="1"/>
           </p:nvPr>
         </p:nvSpPr>
-        <p:spPr/>
+        <p:spPr>
+          <a:xfrm>
+            <a:off x="457200" y="4419600"/>
+            <a:ext cx="5943600" cy="6705600"/>
+          </a:xfrm>
+        </p:spPr>
         <p:txBody>
           <a:bodyPr/>
           <a:lstStyle/>
@@ -605,7 +615,12 @@
             <p:ph type="sldNum" sz="quarter" idx="10"/>
           </p:nvPr>
         </p:nvSpPr>
-        <p:spPr/>
+        <p:spPr>
+          <a:xfrm>
+            <a:off x="3886200" y="11430000"/>
+            <a:ext cx="2514600" cy="457200"/>
+          </a:xfrm>
+        </p:spPr>
         <p:txBody>
           <a:bodyPr/>
           <a:lstStyle/>

</xml_diff>

<commit_message>
Permissions to adapt the slide downloads and the Word templates
Permissions to adapt the slide downloads and the Word templates
</commit_message>
<xml_diff>
--- a/deck/slides/the-ai-control-plane-slide-01.pptx
+++ b/deck/slides/the-ai-control-plane-slide-01.pptx
@@ -597,6 +597,16 @@
                 <a:hlinkClick r:id="rId4"/>
               </a:rPr>
               <a:t>https://johnfisher-ai.github.io/ai-control-plane-handbook/deck/</a:t>
+            </a:r>
+            <a:r>
+              <a:rPr lang="en-US" dirty="0"/>
+              <a:t>. You may adapt this slide, with credit, under the additional permission in the deck’s notices: </a:t>
+            </a:r>
+            <a:r>
+              <a:rPr lang="en-US" dirty="0">
+                <a:hlinkClick r:id="rId5"/>
+              </a:rPr>
+              <a:t>https://johnfisher-ai.github.io/ai-control-plane-handbook/deck/notices.html#permission</a:t>
             </a:r>
             <a:r>
               <a:rPr lang="en-US" dirty="0"/>

</xml_diff>